<commit_message>
feat: add Title and Table layout support to octave-docs
A `##` heading followed by pipe-delimited rows now produces a real
PowerPoint table styled with Octave's registered brand style,
instead of forcing numeric/tabular content into plain bullets.
Motivated by the context-management demo's budget breakdown, which
this updates to actually use a table.

Co-Authored-By: Claude Sonnet 5 <noreply@anthropic.com>
</commit_message>
<xml_diff>
--- a/examples/octave-docs-demo/context-management-demo.pptx
+++ b/examples/octave-docs-demo/context-management-demo.pptx
@@ -16534,37 +16534,188 @@
           </a:p>
         </p:txBody>
       </p:sp>
-      <p:sp>
-        <p:nvSpPr>
-          <p:cNvPr id="3" name="Content Placeholder 2"/>
-          <p:cNvSpPr>
-            <a:spLocks noGrp="1"/>
-          </p:cNvSpPr>
-          <p:nvPr>
-            <p:ph idx="1"/>
-          </p:nvPr>
-        </p:nvSpPr>
-        <p:spPr/>
-        <p:txBody>
-          <a:bodyPr/>
-          <a:lstStyle/>
-          <a:p>
-            <a:r>
-              <a:t>About 7% of the window is gone before you type a word: system instructions ~6k, CLAUDE.md ~3k, tools ~5k</a:t>
-            </a:r>
-          </a:p>
-          <a:p>
-            <a:r>
-              <a:t>The remaining ~168k is the "smart zone" — it shrinks every turn as history accumulates</a:t>
-            </a:r>
-          </a:p>
-          <a:p>
-            <a:r>
-              <a:t>55k is reserved up front: 23k for auto-compact, 32k for output</a:t>
-            </a:r>
-          </a:p>
-        </p:txBody>
-      </p:sp>
+      <p:graphicFrame>
+        <p:nvGraphicFramePr>
+          <p:cNvPr id="3" name="Table 2"/>
+          <p:cNvGraphicFramePr>
+            <a:graphicFrameLocks noGrp="1"/>
+          </p:cNvGraphicFramePr>
+          <p:nvPr/>
+        </p:nvGraphicFramePr>
+        <p:xfrm>
+          <a:off x="1323975" y="1380618"/>
+          <a:ext cx="10487025" cy="2287461"/>
+        </p:xfrm>
+        <a:graphic>
+          <a:graphicData uri="http://schemas.openxmlformats.org/drawingml/2006/table">
+            <a:tbl>
+              <a:tblPr firstRow="1" bandRow="1">
+                <a:tableStyleId>{5C22544A-7EE6-4342-B048-85BDC9FD1C3A}</a:tableStyleId>
+              </a:tblPr>
+              <a:tblGrid>
+                <a:gridCol w="5243512"/>
+                <a:gridCol w="5243513"/>
+              </a:tblGrid>
+              <a:tr h="381243">
+                <a:tc>
+                  <a:txBody>
+                    <a:bodyPr/>
+                    <a:lstStyle/>
+                    <a:p>
+                      <a:r>
+                        <a:t>Line Item</a:t>
+                      </a:r>
+                    </a:p>
+                  </a:txBody>
+                  <a:tcPr/>
+                </a:tc>
+                <a:tc>
+                  <a:txBody>
+                    <a:bodyPr/>
+                    <a:lstStyle/>
+                    <a:p>
+                      <a:r>
+                        <a:t>Tokens</a:t>
+                      </a:r>
+                    </a:p>
+                  </a:txBody>
+                  <a:tcPr/>
+                </a:tc>
+              </a:tr>
+              <a:tr h="381243">
+                <a:tc>
+                  <a:txBody>
+                    <a:bodyPr/>
+                    <a:lstStyle/>
+                    <a:p>
+                      <a:r>
+                        <a:t>System Instructions</a:t>
+                      </a:r>
+                    </a:p>
+                  </a:txBody>
+                  <a:tcPr/>
+                </a:tc>
+                <a:tc>
+                  <a:txBody>
+                    <a:bodyPr/>
+                    <a:lstStyle/>
+                    <a:p>
+                      <a:r>
+                        <a:t>~6k</a:t>
+                      </a:r>
+                    </a:p>
+                  </a:txBody>
+                  <a:tcPr/>
+                </a:tc>
+              </a:tr>
+              <a:tr h="381243">
+                <a:tc>
+                  <a:txBody>
+                    <a:bodyPr/>
+                    <a:lstStyle/>
+                    <a:p>
+                      <a:r>
+                        <a:t>CLAUDE.md</a:t>
+                      </a:r>
+                    </a:p>
+                  </a:txBody>
+                  <a:tcPr/>
+                </a:tc>
+                <a:tc>
+                  <a:txBody>
+                    <a:bodyPr/>
+                    <a:lstStyle/>
+                    <a:p>
+                      <a:r>
+                        <a:t>~3k</a:t>
+                      </a:r>
+                    </a:p>
+                  </a:txBody>
+                  <a:tcPr/>
+                </a:tc>
+              </a:tr>
+              <a:tr h="381243">
+                <a:tc>
+                  <a:txBody>
+                    <a:bodyPr/>
+                    <a:lstStyle/>
+                    <a:p>
+                      <a:r>
+                        <a:t>Tools</a:t>
+                      </a:r>
+                    </a:p>
+                  </a:txBody>
+                  <a:tcPr/>
+                </a:tc>
+                <a:tc>
+                  <a:txBody>
+                    <a:bodyPr/>
+                    <a:lstStyle/>
+                    <a:p>
+                      <a:r>
+                        <a:t>~5k</a:t>
+                      </a:r>
+                    </a:p>
+                  </a:txBody>
+                  <a:tcPr/>
+                </a:tc>
+              </a:tr>
+              <a:tr h="381243">
+                <a:tc>
+                  <a:txBody>
+                    <a:bodyPr/>
+                    <a:lstStyle/>
+                    <a:p>
+                      <a:r>
+                        <a:t>Reserved for auto-compact</a:t>
+                      </a:r>
+                    </a:p>
+                  </a:txBody>
+                  <a:tcPr/>
+                </a:tc>
+                <a:tc>
+                  <a:txBody>
+                    <a:bodyPr/>
+                    <a:lstStyle/>
+                    <a:p>
+                      <a:r>
+                        <a:t>23k</a:t>
+                      </a:r>
+                    </a:p>
+                  </a:txBody>
+                  <a:tcPr/>
+                </a:tc>
+              </a:tr>
+              <a:tr h="381246">
+                <a:tc>
+                  <a:txBody>
+                    <a:bodyPr/>
+                    <a:lstStyle/>
+                    <a:p>
+                      <a:r>
+                        <a:t>Reserved for output</a:t>
+                      </a:r>
+                    </a:p>
+                  </a:txBody>
+                  <a:tcPr/>
+                </a:tc>
+                <a:tc>
+                  <a:txBody>
+                    <a:bodyPr/>
+                    <a:lstStyle/>
+                    <a:p>
+                      <a:r>
+                        <a:t>32k</a:t>
+                      </a:r>
+                    </a:p>
+                  </a:txBody>
+                  <a:tcPr/>
+                </a:tc>
+              </a:tr>
+            </a:tbl>
+          </a:graphicData>
+        </a:graphic>
+      </p:graphicFrame>
     </p:spTree>
   </p:cSld>
   <p:clrMapOvr>

</xml_diff>